<commit_message>
Complément Partikels : relecture du néerlandais et génération des 35 PowerPoint
Co-Authored-By: Claude Opus 5.5 <noreply@anthropic.com>
Claude-Session: https://claude.ai/code/session_01GHo9GbchfMk8JhTz1kwo92
</commit_message>
<xml_diff>
--- a/neerlandais1/powerpoints/Chunks_Apprendre_par_blocs.pptx
+++ b/neerlandais1/powerpoints/Chunks_Apprendre_par_blocs.pptx
@@ -135,18 +135,18 @@
   <p:extLst>
     <p:ext uri="{521415D9-36F7-43E2-AB2F-B90AF26B5E84}">
       <p14:sectionLst xmlns:p14="http://schemas.microsoft.com/office/powerpoint/2010/main">
-        <p14:section name="Ouverture" id="{4c33bb84-a83a-1a42-4d2b-0f367f239390}">
+        <p14:section name="Ouverture" id="{f1d866ca-0297-0424-ee2c-d439da746b5b}">
           <p14:sldIdLst>
             <p14:sldId id="256"/>
           </p14:sldIdLst>
         </p14:section>
-        <p14:section name="Découvrir" id="{7ebac3e0-b86e-9f98-09b8-9e8a5a21c6a3}">
+        <p14:section name="Découvrir" id="{5127e049-9f62-8524-1869-24f72b214b78}">
           <p14:sldIdLst>
             <p14:sldId id="257"/>
             <p14:sldId id="258"/>
           </p14:sldIdLst>
         </p14:section>
-        <p14:section name="Comprendre" id="{94bf3f58-bf1f-8a5c-b62d-4f7c19516cee}">
+        <p14:section name="Comprendre" id="{d7eac168-d102-4465-bd05-e2e7ba3e84d9}">
           <p14:sldIdLst>
             <p14:sldId id="259"/>
             <p14:sldId id="260"/>
@@ -163,7 +163,7 @@
             <p14:sldId id="271"/>
           </p14:sldIdLst>
         </p14:section>
-        <p14:section name="JIJ NU ! — Oefeningen" id="{64328a55-eb63-cd69-6513-ceb596830f56}">
+        <p14:section name="JIJ NU ! — Oefeningen" id="{11fd3639-4471-d408-0263-ac2dcc17e7c6}">
           <p14:sldIdLst>
             <p14:sldId id="272"/>
             <p14:sldId id="273"/>
@@ -179,7 +179,7 @@
             <p14:sldId id="283"/>
           </p14:sldIdLst>
         </p14:section>
-        <p14:section name="Clôture" id="{fe71e429-190d-f435-1b5b-33273bfc5620}">
+        <p14:section name="Clôture" id="{7441f1f2-1c54-54ba-d55c-ddac6084f91b}">
           <p14:sldIdLst>
             <p14:sldId id="284"/>
           </p14:sldIdLst>

</xml_diff>

<commit_message>
Complément Partikels : relecture du néerlandais de la version visuelle et génération des 35 PowerPoint
Co-Authored-By: Claude Opus 5.5 <noreply@anthropic.com>
Claude-Session: https://claude.ai/code/session_01GHo9GbchfMk8JhTz1kwo92
</commit_message>
<xml_diff>
--- a/neerlandais1/powerpoints/Chunks_Apprendre_par_blocs.pptx
+++ b/neerlandais1/powerpoints/Chunks_Apprendre_par_blocs.pptx
@@ -135,18 +135,18 @@
   <p:extLst>
     <p:ext uri="{521415D9-36F7-43E2-AB2F-B90AF26B5E84}">
       <p14:sectionLst xmlns:p14="http://schemas.microsoft.com/office/powerpoint/2010/main">
-        <p14:section name="Ouverture" id="{f1d866ca-0297-0424-ee2c-d439da746b5b}">
+        <p14:section name="Ouverture" id="{f52fd5dd-1267-2e0f-1d74-4ebea8f024bf}">
           <p14:sldIdLst>
             <p14:sldId id="256"/>
           </p14:sldIdLst>
         </p14:section>
-        <p14:section name="Découvrir" id="{5127e049-9f62-8524-1869-24f72b214b78}">
+        <p14:section name="Découvrir" id="{e6d32c29-d5e7-8b1d-23ca-e32be9af6ef3}">
           <p14:sldIdLst>
             <p14:sldId id="257"/>
             <p14:sldId id="258"/>
           </p14:sldIdLst>
         </p14:section>
-        <p14:section name="Comprendre" id="{d7eac168-d102-4465-bd05-e2e7ba3e84d9}">
+        <p14:section name="Comprendre" id="{e4d258cf-d5e3-be83-f7ad-c83d6b440178}">
           <p14:sldIdLst>
             <p14:sldId id="259"/>
             <p14:sldId id="260"/>
@@ -163,7 +163,7 @@
             <p14:sldId id="271"/>
           </p14:sldIdLst>
         </p14:section>
-        <p14:section name="JIJ NU ! — Oefeningen" id="{11fd3639-4471-d408-0263-ac2dcc17e7c6}">
+        <p14:section name="JIJ NU ! — Oefeningen" id="{965e2cf0-f636-18c0-d8b8-05378eb0e776}">
           <p14:sldIdLst>
             <p14:sldId id="272"/>
             <p14:sldId id="273"/>
@@ -179,7 +179,7 @@
             <p14:sldId id="283"/>
           </p14:sldIdLst>
         </p14:section>
-        <p14:section name="Clôture" id="{7441f1f2-1c54-54ba-d55c-ddac6084f91b}">
+        <p14:section name="Clôture" id="{bfe772bd-ca71-66da-86c1-ddaced807211}">
           <p14:sldIdLst>
             <p14:sldId id="284"/>
           </p14:sldIdLst>

</xml_diff>

<commit_message>
Complément Dubbele infinitief : relecture du néerlandais et génération des 36 PowerPoint
Co-Authored-By: Claude Opus 5.5 <noreply@anthropic.com>
Claude-Session: https://claude.ai/code/session_01GHo9GbchfMk8JhTz1kwo92
</commit_message>
<xml_diff>
--- a/neerlandais1/powerpoints/Chunks_Apprendre_par_blocs.pptx
+++ b/neerlandais1/powerpoints/Chunks_Apprendre_par_blocs.pptx
@@ -135,18 +135,18 @@
   <p:extLst>
     <p:ext uri="{521415D9-36F7-43E2-AB2F-B90AF26B5E84}">
       <p14:sectionLst xmlns:p14="http://schemas.microsoft.com/office/powerpoint/2010/main">
-        <p14:section name="Ouverture" id="{f52fd5dd-1267-2e0f-1d74-4ebea8f024bf}">
+        <p14:section name="Ouverture" id="{6ddd9ea5-9d18-f199-fa93-9f3eccf9765b}">
           <p14:sldIdLst>
             <p14:sldId id="256"/>
           </p14:sldIdLst>
         </p14:section>
-        <p14:section name="Découvrir" id="{e6d32c29-d5e7-8b1d-23ca-e32be9af6ef3}">
+        <p14:section name="Découvrir" id="{0b1a61b8-6f11-3148-385d-3fd86c059ef6}">
           <p14:sldIdLst>
             <p14:sldId id="257"/>
             <p14:sldId id="258"/>
           </p14:sldIdLst>
         </p14:section>
-        <p14:section name="Comprendre" id="{e4d258cf-d5e3-be83-f7ad-c83d6b440178}">
+        <p14:section name="Comprendre" id="{fe3b91ee-e771-56b7-4ec8-dbb7c2037fd7}">
           <p14:sldIdLst>
             <p14:sldId id="259"/>
             <p14:sldId id="260"/>
@@ -163,7 +163,7 @@
             <p14:sldId id="271"/>
           </p14:sldIdLst>
         </p14:section>
-        <p14:section name="JIJ NU ! — Oefeningen" id="{965e2cf0-f636-18c0-d8b8-05378eb0e776}">
+        <p14:section name="JIJ NU ! — Oefeningen" id="{421fa110-704e-a144-ca1a-974e1d24d13a}">
           <p14:sldIdLst>
             <p14:sldId id="272"/>
             <p14:sldId id="273"/>
@@ -179,7 +179,7 @@
             <p14:sldId id="283"/>
           </p14:sldIdLst>
         </p14:section>
-        <p14:section name="Clôture" id="{bfe772bd-ca71-66da-86c1-ddaced807211}">
+        <p14:section name="Clôture" id="{eb1ff34b-1048-af6f-570e-5bfdfc34d903}">
           <p14:sldIdLst>
             <p14:sldId id="284"/>
           </p14:sldIdLst>

</xml_diff>

<commit_message>
Compléments te / om … te et emplois de er : relecture du néerlandais et génération des 38 PowerPoint
Co-Authored-By: Claude Opus 5.5 <noreply@anthropic.com>
Claude-Session: https://claude.ai/code/session_01GHo9GbchfMk8JhTz1kwo92
</commit_message>
<xml_diff>
--- a/neerlandais1/powerpoints/Chunks_Apprendre_par_blocs.pptx
+++ b/neerlandais1/powerpoints/Chunks_Apprendre_par_blocs.pptx
@@ -135,18 +135,18 @@
   <p:extLst>
     <p:ext uri="{521415D9-36F7-43E2-AB2F-B90AF26B5E84}">
       <p14:sectionLst xmlns:p14="http://schemas.microsoft.com/office/powerpoint/2010/main">
-        <p14:section name="Ouverture" id="{6ddd9ea5-9d18-f199-fa93-9f3eccf9765b}">
+        <p14:section name="Ouverture" id="{2e7dc2f4-c7eb-676d-bda4-7ce841c23cce}">
           <p14:sldIdLst>
             <p14:sldId id="256"/>
           </p14:sldIdLst>
         </p14:section>
-        <p14:section name="Découvrir" id="{0b1a61b8-6f11-3148-385d-3fd86c059ef6}">
+        <p14:section name="Découvrir" id="{e9162ff0-51ac-44fa-0963-6a4c481252b2}">
           <p14:sldIdLst>
             <p14:sldId id="257"/>
             <p14:sldId id="258"/>
           </p14:sldIdLst>
         </p14:section>
-        <p14:section name="Comprendre" id="{fe3b91ee-e771-56b7-4ec8-dbb7c2037fd7}">
+        <p14:section name="Comprendre" id="{31ba2377-faaf-cba7-2750-52177443039c}">
           <p14:sldIdLst>
             <p14:sldId id="259"/>
             <p14:sldId id="260"/>
@@ -163,7 +163,7 @@
             <p14:sldId id="271"/>
           </p14:sldIdLst>
         </p14:section>
-        <p14:section name="JIJ NU ! — Oefeningen" id="{421fa110-704e-a144-ca1a-974e1d24d13a}">
+        <p14:section name="JIJ NU ! — Oefeningen" id="{97ac0de3-c63b-3fd2-6c3f-edf4ad203ebc}">
           <p14:sldIdLst>
             <p14:sldId id="272"/>
             <p14:sldId id="273"/>
@@ -179,7 +179,7 @@
             <p14:sldId id="283"/>
           </p14:sldIdLst>
         </p14:section>
-        <p14:section name="Clôture" id="{eb1ff34b-1048-af6f-570e-5bfdfc34d903}">
+        <p14:section name="Clôture" id="{425fae22-3a6d-1741-515f-0d5be31ad808}">
           <p14:sldIdLst>
             <p14:sldId id="284"/>
           </p14:sldIdLst>

</xml_diff>

<commit_message>
Ajoute les compléments Relier les phrases et Les temps sur la ligne du temps (relecture appliquée, 40 decks régénérés)
Co-Authored-By: Claude Opus 5.5 <noreply@anthropic.com>
Claude-Session: https://claude.ai/code/session_01GHo9GbchfMk8JhTz1kwo92
</commit_message>
<xml_diff>
--- a/neerlandais1/powerpoints/Chunks_Apprendre_par_blocs.pptx
+++ b/neerlandais1/powerpoints/Chunks_Apprendre_par_blocs.pptx
@@ -135,18 +135,18 @@
   <p:extLst>
     <p:ext uri="{521415D9-36F7-43E2-AB2F-B90AF26B5E84}">
       <p14:sectionLst xmlns:p14="http://schemas.microsoft.com/office/powerpoint/2010/main">
-        <p14:section name="Ouverture" id="{2e7dc2f4-c7eb-676d-bda4-7ce841c23cce}">
+        <p14:section name="Ouverture" id="{ac78782a-d586-7d60-4b43-8fd0b71c4829}">
           <p14:sldIdLst>
             <p14:sldId id="256"/>
           </p14:sldIdLst>
         </p14:section>
-        <p14:section name="Découvrir" id="{e9162ff0-51ac-44fa-0963-6a4c481252b2}">
+        <p14:section name="Découvrir" id="{08ee615c-d1df-0c6b-6df9-cbc4a2a9d105}">
           <p14:sldIdLst>
             <p14:sldId id="257"/>
             <p14:sldId id="258"/>
           </p14:sldIdLst>
         </p14:section>
-        <p14:section name="Comprendre" id="{31ba2377-faaf-cba7-2750-52177443039c}">
+        <p14:section name="Comprendre" id="{6b1fb161-7015-3655-d817-85b8ae40e2e1}">
           <p14:sldIdLst>
             <p14:sldId id="259"/>
             <p14:sldId id="260"/>
@@ -163,7 +163,7 @@
             <p14:sldId id="271"/>
           </p14:sldIdLst>
         </p14:section>
-        <p14:section name="JIJ NU ! — Oefeningen" id="{97ac0de3-c63b-3fd2-6c3f-edf4ad203ebc}">
+        <p14:section name="JIJ NU ! — Oefeningen" id="{56b1764b-97a5-191f-3da1-6ff9e7dd8ad3}">
           <p14:sldIdLst>
             <p14:sldId id="272"/>
             <p14:sldId id="273"/>
@@ -179,7 +179,7 @@
             <p14:sldId id="283"/>
           </p14:sldIdLst>
         </p14:section>
-        <p14:section name="Clôture" id="{425fae22-3a6d-1741-515f-0d5be31ad808}">
+        <p14:section name="Clôture" id="{5b7b6b87-2ded-c835-78b3-03c839cb5149}">
           <p14:sldIdLst>
             <p14:sldId id="284"/>
           </p14:sldIdLst>

</xml_diff>

<commit_message>
Ajoute le complément La dérivation (relecture appliquée, 41 decks régénérés)
Co-Authored-By: Claude Opus 5.5 <noreply@anthropic.com>
Claude-Session: https://claude.ai/code/session_01GHo9GbchfMk8JhTz1kwo92
</commit_message>
<xml_diff>
--- a/neerlandais1/powerpoints/Chunks_Apprendre_par_blocs.pptx
+++ b/neerlandais1/powerpoints/Chunks_Apprendre_par_blocs.pptx
@@ -135,18 +135,18 @@
   <p:extLst>
     <p:ext uri="{521415D9-36F7-43E2-AB2F-B90AF26B5E84}">
       <p14:sectionLst xmlns:p14="http://schemas.microsoft.com/office/powerpoint/2010/main">
-        <p14:section name="Ouverture" id="{ac78782a-d586-7d60-4b43-8fd0b71c4829}">
+        <p14:section name="Ouverture" id="{671ac591-d9f6-3ae6-c697-93567a257f99}">
           <p14:sldIdLst>
             <p14:sldId id="256"/>
           </p14:sldIdLst>
         </p14:section>
-        <p14:section name="Découvrir" id="{08ee615c-d1df-0c6b-6df9-cbc4a2a9d105}">
+        <p14:section name="Découvrir" id="{5a165570-65d6-6b63-bf6a-c82e4dae3333}">
           <p14:sldIdLst>
             <p14:sldId id="257"/>
             <p14:sldId id="258"/>
           </p14:sldIdLst>
         </p14:section>
-        <p14:section name="Comprendre" id="{6b1fb161-7015-3655-d817-85b8ae40e2e1}">
+        <p14:section name="Comprendre" id="{dff0476a-d975-d9d4-5cc1-dfe152d75de2}">
           <p14:sldIdLst>
             <p14:sldId id="259"/>
             <p14:sldId id="260"/>
@@ -163,7 +163,7 @@
             <p14:sldId id="271"/>
           </p14:sldIdLst>
         </p14:section>
-        <p14:section name="JIJ NU ! — Oefeningen" id="{56b1764b-97a5-191f-3da1-6ff9e7dd8ad3}">
+        <p14:section name="JIJ NU ! — Oefeningen" id="{78c7d10d-a248-9fcd-f69d-f4d78603aa17}">
           <p14:sldIdLst>
             <p14:sldId id="272"/>
             <p14:sldId id="273"/>
@@ -179,7 +179,7 @@
             <p14:sldId id="283"/>
           </p14:sldIdLst>
         </p14:section>
-        <p14:section name="Clôture" id="{5b7b6b87-2ded-c835-78b3-03c839cb5149}">
+        <p14:section name="Clôture" id="{ceb0862c-995e-5bbe-ac65-20f1ffff14f2}">
           <p14:sldIdLst>
             <p14:sldId id="284"/>
           </p14:sldIdLst>

</xml_diff>

<commit_message>
Ajoute le jeu de rôle Goedemorgen, collega! (A1, après la 2e séance)
Co-Authored-By: Claude Opus 5.5 <noreply@anthropic.com>
Claude-Session: https://claude.ai/code/session_01GHo9GbchfMk8JhTz1kwo92
</commit_message>
<xml_diff>
--- a/neerlandais1/powerpoints/Chunks_Apprendre_par_blocs.pptx
+++ b/neerlandais1/powerpoints/Chunks_Apprendre_par_blocs.pptx
@@ -135,18 +135,18 @@
   <p:extLst>
     <p:ext uri="{521415D9-36F7-43E2-AB2F-B90AF26B5E84}">
       <p14:sectionLst xmlns:p14="http://schemas.microsoft.com/office/powerpoint/2010/main">
-        <p14:section name="Ouverture" id="{671ac591-d9f6-3ae6-c697-93567a257f99}">
+        <p14:section name="Ouverture" id="{bcc8a154-606d-af3d-41aa-4c460e02a9bc}">
           <p14:sldIdLst>
             <p14:sldId id="256"/>
           </p14:sldIdLst>
         </p14:section>
-        <p14:section name="Découvrir" id="{5a165570-65d6-6b63-bf6a-c82e4dae3333}">
+        <p14:section name="Découvrir" id="{e9741b81-4683-8128-b1f7-7270d876cb84}">
           <p14:sldIdLst>
             <p14:sldId id="257"/>
             <p14:sldId id="258"/>
           </p14:sldIdLst>
         </p14:section>
-        <p14:section name="Comprendre" id="{dff0476a-d975-d9d4-5cc1-dfe152d75de2}">
+        <p14:section name="Comprendre" id="{c630b6e6-cafa-67c9-d5e8-81ab4cf39e8d}">
           <p14:sldIdLst>
             <p14:sldId id="259"/>
             <p14:sldId id="260"/>
@@ -163,7 +163,7 @@
             <p14:sldId id="271"/>
           </p14:sldIdLst>
         </p14:section>
-        <p14:section name="JIJ NU ! — Oefeningen" id="{78c7d10d-a248-9fcd-f69d-f4d78603aa17}">
+        <p14:section name="JIJ NU ! — Oefeningen" id="{822f1476-6192-3bd4-a6db-e38efe638d4f}">
           <p14:sldIdLst>
             <p14:sldId id="272"/>
             <p14:sldId id="273"/>
@@ -179,7 +179,7 @@
             <p14:sldId id="283"/>
           </p14:sldIdLst>
         </p14:section>
-        <p14:section name="Clôture" id="{ceb0862c-995e-5bbe-ac65-20f1ffff14f2}">
+        <p14:section name="Clôture" id="{10422295-dddb-3d9c-8bb0-d7407fa3aa96}">
           <p14:sldIdLst>
             <p14:sldId id="284"/>
           </p14:sldIdLst>

</xml_diff>